<commit_message>
docs: shorten refactoring notebook for one-hour live session
Replace the 51-line sales script and seven full-script steps with a
23-line script and four steps that each show only the new function.
Point slide 16 to the sales script instead of the Sudoku solver.
</commit_message>
<xml_diff>
--- a/basics/8_refactoring/Refactoring_Code_Qualität_LS8_PYB.pptx
+++ b/basics/8_refactoring/Refactoring_Code_Qualität_LS8_PYB.pptx
@@ -14071,7 +14071,7 @@
           <a:p>
             <a:r>
               <a:rPr lang="de-DE" b="1" dirty="0"/>
-              <a:t>Der Sudoku-Löser als Praxisbeispiel</a:t>
+              <a:t>Das Verkaufsskript als Praxisbeispiel</a:t>
             </a:r>
           </a:p>
         </p:txBody>
@@ -14114,7 +14114,7 @@
             </a:r>
             <a:r>
               <a:rPr lang="de-DE" sz="2400" dirty="0"/>
-              <a:t>“ und Stilbrüchen im Beispiel eines Sudoku-Lösers</a:t>
+              <a:t>“ und Stilbrüchen in einem gewachsenen Auswertungsskript für Verkaufsdaten</a:t>
             </a:r>
           </a:p>
           <a:p>

</xml_diff>